<commit_message>
Update for PIAAC book chapter publication Many variable fields updated (see df17 in the code workflow)
</commit_message>
<xml_diff>
--- a/Shiny/www/Fig1.pptx
+++ b/Shiny/www/Fig1.pptx
@@ -260,7 +260,7 @@
           <a:p>
             <a:fld id="{79D02E35-BBA4-4E24-9F73-ACDCB6F88B1E}" type="datetimeFigureOut">
               <a:rPr lang="en-US" smtClean="0"/>
-              <a:t>7/24/2025</a:t>
+              <a:t>9/26/2025</a:t>
             </a:fld>
             <a:endParaRPr lang="en-US"/>
           </a:p>
@@ -458,7 +458,7 @@
           <a:p>
             <a:fld id="{79D02E35-BBA4-4E24-9F73-ACDCB6F88B1E}" type="datetimeFigureOut">
               <a:rPr lang="en-US" smtClean="0"/>
-              <a:t>7/24/2025</a:t>
+              <a:t>9/26/2025</a:t>
             </a:fld>
             <a:endParaRPr lang="en-US"/>
           </a:p>
@@ -666,7 +666,7 @@
           <a:p>
             <a:fld id="{79D02E35-BBA4-4E24-9F73-ACDCB6F88B1E}" type="datetimeFigureOut">
               <a:rPr lang="en-US" smtClean="0"/>
-              <a:t>7/24/2025</a:t>
+              <a:t>9/26/2025</a:t>
             </a:fld>
             <a:endParaRPr lang="en-US"/>
           </a:p>
@@ -864,7 +864,7 @@
           <a:p>
             <a:fld id="{79D02E35-BBA4-4E24-9F73-ACDCB6F88B1E}" type="datetimeFigureOut">
               <a:rPr lang="en-US" smtClean="0"/>
-              <a:t>7/24/2025</a:t>
+              <a:t>9/26/2025</a:t>
             </a:fld>
             <a:endParaRPr lang="en-US"/>
           </a:p>
@@ -1139,7 +1139,7 @@
           <a:p>
             <a:fld id="{79D02E35-BBA4-4E24-9F73-ACDCB6F88B1E}" type="datetimeFigureOut">
               <a:rPr lang="en-US" smtClean="0"/>
-              <a:t>7/24/2025</a:t>
+              <a:t>9/26/2025</a:t>
             </a:fld>
             <a:endParaRPr lang="en-US"/>
           </a:p>
@@ -1404,7 +1404,7 @@
           <a:p>
             <a:fld id="{79D02E35-BBA4-4E24-9F73-ACDCB6F88B1E}" type="datetimeFigureOut">
               <a:rPr lang="en-US" smtClean="0"/>
-              <a:t>7/24/2025</a:t>
+              <a:t>9/26/2025</a:t>
             </a:fld>
             <a:endParaRPr lang="en-US"/>
           </a:p>
@@ -1816,7 +1816,7 @@
           <a:p>
             <a:fld id="{79D02E35-BBA4-4E24-9F73-ACDCB6F88B1E}" type="datetimeFigureOut">
               <a:rPr lang="en-US" smtClean="0"/>
-              <a:t>7/24/2025</a:t>
+              <a:t>9/26/2025</a:t>
             </a:fld>
             <a:endParaRPr lang="en-US"/>
           </a:p>
@@ -1957,7 +1957,7 @@
           <a:p>
             <a:fld id="{79D02E35-BBA4-4E24-9F73-ACDCB6F88B1E}" type="datetimeFigureOut">
               <a:rPr lang="en-US" smtClean="0"/>
-              <a:t>7/24/2025</a:t>
+              <a:t>9/26/2025</a:t>
             </a:fld>
             <a:endParaRPr lang="en-US"/>
           </a:p>
@@ -2070,7 +2070,7 @@
           <a:p>
             <a:fld id="{79D02E35-BBA4-4E24-9F73-ACDCB6F88B1E}" type="datetimeFigureOut">
               <a:rPr lang="en-US" smtClean="0"/>
-              <a:t>7/24/2025</a:t>
+              <a:t>9/26/2025</a:t>
             </a:fld>
             <a:endParaRPr lang="en-US"/>
           </a:p>
@@ -2381,7 +2381,7 @@
           <a:p>
             <a:fld id="{79D02E35-BBA4-4E24-9F73-ACDCB6F88B1E}" type="datetimeFigureOut">
               <a:rPr lang="en-US" smtClean="0"/>
-              <a:t>7/24/2025</a:t>
+              <a:t>9/26/2025</a:t>
             </a:fld>
             <a:endParaRPr lang="en-US"/>
           </a:p>
@@ -2669,7 +2669,7 @@
           <a:p>
             <a:fld id="{79D02E35-BBA4-4E24-9F73-ACDCB6F88B1E}" type="datetimeFigureOut">
               <a:rPr lang="en-US" smtClean="0"/>
-              <a:t>7/24/2025</a:t>
+              <a:t>9/26/2025</a:t>
             </a:fld>
             <a:endParaRPr lang="en-US"/>
           </a:p>
@@ -2910,7 +2910,7 @@
           <a:p>
             <a:fld id="{79D02E35-BBA4-4E24-9F73-ACDCB6F88B1E}" type="datetimeFigureOut">
               <a:rPr lang="en-US" smtClean="0"/>
-              <a:t>7/24/2025</a:t>
+              <a:t>9/26/2025</a:t>
             </a:fld>
             <a:endParaRPr lang="en-US"/>
           </a:p>
@@ -3329,10 +3329,10 @@
       </p:grpSpPr>
       <p:pic>
         <p:nvPicPr>
-          <p:cNvPr id="5" name="Picture 4">
-            <a:extLst>
-              <a:ext uri="{FF2B5EF4-FFF2-40B4-BE49-F238E27FC236}">
-                <a16:creationId xmlns:a16="http://schemas.microsoft.com/office/drawing/2014/main" id="{A076400B-81F9-3D09-F43F-78EE58F38656}"/>
+          <p:cNvPr id="19" name="Picture 18">
+            <a:extLst>
+              <a:ext uri="{FF2B5EF4-FFF2-40B4-BE49-F238E27FC236}">
+                <a16:creationId xmlns:a16="http://schemas.microsoft.com/office/drawing/2014/main" id="{87BFBD99-36A2-0195-FC34-C847387711EE}"/>
               </a:ext>
             </a:extLst>
           </p:cNvPr>
@@ -3342,8 +3342,14 @@
           <p:nvPr/>
         </p:nvPicPr>
         <p:blipFill>
-          <a:blip r:embed="rId2"/>
-          <a:srcRect t="15772" r="1491" b="6342"/>
+          <a:blip r:embed="rId2">
+            <a:extLst>
+              <a:ext uri="{28A0092B-C50C-407E-A947-70E740481C1C}">
+                <a14:useLocalDpi xmlns:a14="http://schemas.microsoft.com/office/drawing/2010/main" val="0"/>
+              </a:ext>
+            </a:extLst>
+          </a:blip>
+          <a:srcRect r="19569" b="18573"/>
           <a:stretch>
             <a:fillRect/>
           </a:stretch>
@@ -3351,7 +3357,7 @@
         <p:spPr>
           <a:xfrm>
             <a:off x="366750" y="597868"/>
-            <a:ext cx="11458499" cy="5662264"/>
+            <a:ext cx="10415942" cy="5662264"/>
           </a:xfrm>
           <a:prstGeom prst="rect">
             <a:avLst/>

</xml_diff>